<commit_message>
docs: update project status and methodology details in executive presentation
</commit_message>
<xml_diff>
--- a/presentations/presentacion-bcv-skills-ia-ntt-data-roadmap-v2.pptx
+++ b/presentations/presentacion-bcv-skills-ia-ntt-data-roadmap-v2.pptx
@@ -29,6 +29,7 @@
     <p:sldId id="277" r:id="rId23"/>
     <p:sldId id="278" r:id="rId24"/>
     <p:sldId id="279" r:id="rId25"/>
+    <p:sldId id="289" r:id="rId40"/>
     <p:sldId id="281" r:id="rId27"/>
     <p:sldId id="282" r:id="rId28"/>
     <p:sldId id="283" r:id="rId29"/>
@@ -136,6 +137,603 @@
     </a:lvl9pPr>
   </p:defaultTextStyle>
 </p:presentation>
+</file>
+
+<file path=ppt/charts/chart1.xml><?xml version="1.0" encoding="utf-8"?>
+<c:chartSpace xmlns:c="http://schemas.openxmlformats.org/drawingml/2006/chart" xmlns:a="http://schemas.openxmlformats.org/drawingml/2006/main" xmlns:r="http://schemas.openxmlformats.org/officeDocument/2006/relationships">
+  <c:date1904 val="0"/>
+  <c:chart>
+    <c:title>
+      <c:tx>
+        <c:rich>
+          <a:bodyPr/>
+          <a:lstStyle/>
+          <a:p>
+            <a:r>
+              <a:rPr sz="1300" b="1">
+                <a:solidFill>
+                  <a:srgbClr val="FFFFFF"/>
+                </a:solidFill>
+                <a:latin typeface="Noto Sans"/>
+              </a:rPr>
+              <a:t>3 de 8 semanas completadas</a:t>
+            </a:r>
+          </a:p>
+        </c:rich>
+      </c:tx>
+      <c:layout/>
+      <c:overlay val="0"/>
+    </c:title>
+    <c:autoTitleDeleted val="0"/>
+    <c:plotArea>
+      <c:barChart>
+        <c:barDir val="bar"/>
+        <c:grouping val="percentStacked"/>
+        <c:ser>
+          <c:idx val="0"/>
+          <c:order val="0"/>
+          <c:tx>
+            <c:strRef>
+              <c:f>Sheet1!$B$1</c:f>
+              <c:strCache>
+                <c:ptCount val="1"/>
+                <c:pt idx="0">
+                  <c:v>Completada</c:v>
+                </c:pt>
+              </c:strCache>
+            </c:strRef>
+          </c:tx>
+          <c:spPr>
+            <a:solidFill>
+              <a:srgbClr val="00CB5D"/>
+            </a:solidFill>
+            <a:ln>
+              <a:noFill/>
+            </a:ln>
+          </c:spPr>
+          <c:dLbls>
+            <c:txPr>
+              <a:bodyPr/>
+              <a:lstStyle/>
+              <a:p>
+                <a:pPr>
+                  <a:defRPr>
+                    <a:solidFill>
+                      <a:srgbClr val="FFFFFF"/>
+                    </a:solidFill>
+                  </a:defRPr>
+                </a:pPr>
+              </a:p>
+            </c:txPr>
+            <c:showLegendKey val="0"/>
+            <c:showVal val="1"/>
+            <c:showCatName val="0"/>
+            <c:showSerName val="0"/>
+            <c:showPercent val="0"/>
+            <c:showBubbleSize val="0"/>
+            <c:showLeaderLines val="1"/>
+          </c:dLbls>
+          <c:cat>
+            <c:strRef>
+              <c:f>Sheet1!$A$2:$A$2</c:f>
+              <c:strCache>
+                <c:ptCount val="1"/>
+                <c:pt idx="0">
+                  <c:v>Semanas 1–8</c:v>
+                </c:pt>
+              </c:strCache>
+            </c:strRef>
+          </c:cat>
+          <c:val>
+            <c:numRef>
+              <c:f>Sheet1!$B$2:$B$2</c:f>
+              <c:numCache>
+                <c:formatCode>General</c:formatCode>
+                <c:ptCount val="1"/>
+                <c:pt idx="0">
+                  <c:v>3</c:v>
+                </c:pt>
+              </c:numCache>
+            </c:numRef>
+          </c:val>
+        </c:ser>
+        <c:ser>
+          <c:idx val="1"/>
+          <c:order val="1"/>
+          <c:tx>
+            <c:strRef>
+              <c:f>Sheet1!$C$1</c:f>
+              <c:strCache>
+                <c:ptCount val="1"/>
+                <c:pt idx="0">
+                  <c:v>En curso</c:v>
+                </c:pt>
+              </c:strCache>
+            </c:strRef>
+          </c:tx>
+          <c:spPr>
+            <a:solidFill>
+              <a:srgbClr val="F9E795"/>
+            </a:solidFill>
+            <a:ln>
+              <a:noFill/>
+            </a:ln>
+          </c:spPr>
+          <c:dLbls>
+            <c:txPr>
+              <a:bodyPr/>
+              <a:lstStyle/>
+              <a:p>
+                <a:pPr>
+                  <a:defRPr>
+                    <a:solidFill>
+                      <a:srgbClr val="0A1A2E"/>
+                    </a:solidFill>
+                  </a:defRPr>
+                </a:pPr>
+              </a:p>
+            </c:txPr>
+            <c:showLegendKey val="0"/>
+            <c:showVal val="1"/>
+            <c:showCatName val="0"/>
+            <c:showSerName val="0"/>
+            <c:showPercent val="0"/>
+            <c:showBubbleSize val="0"/>
+            <c:showLeaderLines val="1"/>
+          </c:dLbls>
+          <c:cat>
+            <c:strRef>
+              <c:f>Sheet1!$A$2:$A$2</c:f>
+              <c:strCache>
+                <c:ptCount val="1"/>
+                <c:pt idx="0">
+                  <c:v>Semanas 1–8</c:v>
+                </c:pt>
+              </c:strCache>
+            </c:strRef>
+          </c:cat>
+          <c:val>
+            <c:numRef>
+              <c:f>Sheet1!$C$2:$C$2</c:f>
+              <c:numCache>
+                <c:formatCode>General</c:formatCode>
+                <c:ptCount val="1"/>
+                <c:pt idx="0">
+                  <c:v>1</c:v>
+                </c:pt>
+              </c:numCache>
+            </c:numRef>
+          </c:val>
+        </c:ser>
+        <c:ser>
+          <c:idx val="2"/>
+          <c:order val="2"/>
+          <c:tx>
+            <c:strRef>
+              <c:f>Sheet1!$D$1</c:f>
+              <c:strCache>
+                <c:ptCount val="1"/>
+                <c:pt idx="0">
+                  <c:v>Propuesto</c:v>
+                </c:pt>
+              </c:strCache>
+            </c:strRef>
+          </c:tx>
+          <c:spPr>
+            <a:solidFill>
+              <a:srgbClr val="1A2B4A"/>
+            </a:solidFill>
+            <a:ln>
+              <a:noFill/>
+            </a:ln>
+          </c:spPr>
+          <c:dLbls>
+            <c:txPr>
+              <a:bodyPr/>
+              <a:lstStyle/>
+              <a:p>
+                <a:pPr>
+                  <a:defRPr>
+                    <a:solidFill>
+                      <a:srgbClr val="FFFFFF"/>
+                    </a:solidFill>
+                  </a:defRPr>
+                </a:pPr>
+              </a:p>
+            </c:txPr>
+            <c:showLegendKey val="0"/>
+            <c:showVal val="1"/>
+            <c:showCatName val="0"/>
+            <c:showSerName val="0"/>
+            <c:showPercent val="0"/>
+            <c:showBubbleSize val="0"/>
+            <c:showLeaderLines val="1"/>
+          </c:dLbls>
+          <c:cat>
+            <c:strRef>
+              <c:f>Sheet1!$A$2:$A$2</c:f>
+              <c:strCache>
+                <c:ptCount val="1"/>
+                <c:pt idx="0">
+                  <c:v>Semanas 1–8</c:v>
+                </c:pt>
+              </c:strCache>
+            </c:strRef>
+          </c:cat>
+          <c:val>
+            <c:numRef>
+              <c:f>Sheet1!$D$2:$D$2</c:f>
+              <c:numCache>
+                <c:formatCode>General</c:formatCode>
+                <c:ptCount val="1"/>
+                <c:pt idx="0">
+                  <c:v>4</c:v>
+                </c:pt>
+              </c:numCache>
+            </c:numRef>
+          </c:val>
+        </c:ser>
+        <c:dLbls>
+          <c:numFmt formatCode="0" sourceLinked="0"/>
+          <c:txPr>
+            <a:bodyPr/>
+            <a:lstStyle/>
+            <a:p>
+              <a:pPr>
+                <a:defRPr sz="1100" b="1"/>
+              </a:pPr>
+            </a:p>
+          </c:txPr>
+          <c:dLblPos val="ctr"/>
+          <c:showLegendKey val="0"/>
+          <c:showVal val="1"/>
+          <c:showCatName val="0"/>
+          <c:showSerName val="0"/>
+          <c:showPercent val="0"/>
+          <c:showBubbleSize val="0"/>
+          <c:showLeaderLines val="1"/>
+        </c:dLbls>
+        <c:overlap val="100"/>
+        <c:axId val="-2068027336"/>
+        <c:axId val="-2113994440"/>
+      </c:barChart>
+      <c:catAx>
+        <c:axId val="-2068027336"/>
+        <c:scaling>
+          <c:orientation val="minMax"/>
+        </c:scaling>
+        <c:delete/>
+        <c:axPos val="l"/>
+        <c:majorTickMark val="out"/>
+        <c:minorTickMark val="none"/>
+        <c:tickLblPos val="nextTo"/>
+        <c:crossAx val="-2113994440"/>
+        <c:crosses val="autoZero"/>
+        <c:auto val="1"/>
+        <c:lblAlgn val="ctr"/>
+        <c:lblOffset val="100"/>
+        <c:noMultiLvlLbl val="0"/>
+      </c:catAx>
+      <c:valAx>
+        <c:axId val="-2113994440"/>
+        <c:scaling/>
+        <c:delete/>
+        <c:axPos val="b"/>
+        <c:majorTickMark val="out"/>
+        <c:minorTickMark val="none"/>
+        <c:tickLblPos val="nextTo"/>
+        <c:crossAx val="-2068027336"/>
+        <c:crosses val="autoZero"/>
+      </c:valAx>
+    </c:plotArea>
+    <c:legend>
+      <c:legendPos val="b"/>
+      <c:overlay val="0"/>
+      <c:txPr>
+        <a:bodyPr/>
+        <a:lstStyle/>
+        <a:p>
+          <a:pPr>
+            <a:defRPr sz="1000">
+              <a:solidFill>
+                <a:srgbClr val="D6D6D6"/>
+              </a:solidFill>
+              <a:latin typeface="Arial"/>
+            </a:defRPr>
+          </a:pPr>
+        </a:p>
+      </c:txPr>
+    </c:legend>
+    <c:dispBlanksAs val="gap"/>
+  </c:chart>
+  <c:txPr>
+    <a:bodyPr/>
+    <a:lstStyle/>
+    <a:p>
+      <a:pPr>
+        <a:defRPr sz="1800"/>
+      </a:pPr>
+      <a:endParaRPr lang="en-US"/>
+    </a:p>
+  </c:txPr>
+  <c:externalData r:id="rId1">
+    <c:autoUpdate val="0"/>
+  </c:externalData>
+</c:chartSpace>
+</file>
+
+<file path=ppt/charts/chart2.xml><?xml version="1.0" encoding="utf-8"?>
+<c:chartSpace xmlns:c="http://schemas.openxmlformats.org/drawingml/2006/chart" xmlns:a="http://schemas.openxmlformats.org/drawingml/2006/main" xmlns:r="http://schemas.openxmlformats.org/officeDocument/2006/relationships">
+  <c:date1904 val="0"/>
+  <c:chart>
+    <c:title>
+      <c:tx>
+        <c:rich>
+          <a:bodyPr/>
+          <a:lstStyle/>
+          <a:p>
+            <a:r>
+              <a:rPr sz="1300" b="1">
+                <a:solidFill>
+                  <a:srgbClr val="FFFFFF"/>
+                </a:solidFill>
+                <a:latin typeface="Noto Sans"/>
+              </a:rPr>
+              <a:t>Estado semana a semana</a:t>
+            </a:r>
+          </a:p>
+        </c:rich>
+      </c:tx>
+      <c:layout/>
+      <c:overlay val="0"/>
+    </c:title>
+    <c:autoTitleDeleted val="0"/>
+    <c:plotArea>
+      <c:barChart>
+        <c:barDir val="col"/>
+        <c:grouping val="clustered"/>
+        <c:varyColors/>
+        <c:ser>
+          <c:idx val="0"/>
+          <c:order val="0"/>
+          <c:tx>
+            <c:strRef>
+              <c:f>Sheet1!$B$1</c:f>
+              <c:strCache>
+                <c:ptCount val="1"/>
+                <c:pt idx="0">
+                  <c:v>Estado</c:v>
+                </c:pt>
+              </c:strCache>
+            </c:strRef>
+          </c:tx>
+          <c:dPt>
+            <c:idx val="0"/>
+            <c:spPr>
+              <a:solidFill>
+                <a:srgbClr val="00CB5D"/>
+              </a:solidFill>
+              <a:ln>
+                <a:noFill/>
+              </a:ln>
+            </c:spPr>
+          </c:dPt>
+          <c:dPt>
+            <c:idx val="1"/>
+            <c:spPr>
+              <a:solidFill>
+                <a:srgbClr val="00CB5D"/>
+              </a:solidFill>
+              <a:ln>
+                <a:noFill/>
+              </a:ln>
+            </c:spPr>
+          </c:dPt>
+          <c:dPt>
+            <c:idx val="2"/>
+            <c:spPr>
+              <a:solidFill>
+                <a:srgbClr val="00CB5D"/>
+              </a:solidFill>
+              <a:ln>
+                <a:noFill/>
+              </a:ln>
+            </c:spPr>
+          </c:dPt>
+          <c:dPt>
+            <c:idx val="3"/>
+            <c:spPr>
+              <a:solidFill>
+                <a:srgbClr val="F9E795"/>
+              </a:solidFill>
+              <a:ln>
+                <a:noFill/>
+              </a:ln>
+            </c:spPr>
+          </c:dPt>
+          <c:dPt>
+            <c:idx val="4"/>
+            <c:spPr>
+              <a:solidFill>
+                <a:srgbClr val="1A2B4A"/>
+              </a:solidFill>
+              <a:ln>
+                <a:noFill/>
+              </a:ln>
+            </c:spPr>
+          </c:dPt>
+          <c:dPt>
+            <c:idx val="5"/>
+            <c:spPr>
+              <a:solidFill>
+                <a:srgbClr val="1A2B4A"/>
+              </a:solidFill>
+              <a:ln>
+                <a:noFill/>
+              </a:ln>
+            </c:spPr>
+          </c:dPt>
+          <c:dPt>
+            <c:idx val="6"/>
+            <c:spPr>
+              <a:solidFill>
+                <a:srgbClr val="1A2B4A"/>
+              </a:solidFill>
+              <a:ln>
+                <a:noFill/>
+              </a:ln>
+            </c:spPr>
+          </c:dPt>
+          <c:dPt>
+            <c:idx val="7"/>
+            <c:spPr>
+              <a:solidFill>
+                <a:srgbClr val="1A2B4A"/>
+              </a:solidFill>
+              <a:ln>
+                <a:noFill/>
+              </a:ln>
+            </c:spPr>
+          </c:dPt>
+          <c:cat>
+            <c:strRef>
+              <c:f>Sheet1!$A$2:$A$9</c:f>
+              <c:strCache>
+                <c:ptCount val="8"/>
+                <c:pt idx="0">
+                  <c:v>Sem 1</c:v>
+                </c:pt>
+                <c:pt idx="1">
+                  <c:v>Sem 2</c:v>
+                </c:pt>
+                <c:pt idx="2">
+                  <c:v>Sem 3</c:v>
+                </c:pt>
+                <c:pt idx="3">
+                  <c:v>Sem 4</c:v>
+                </c:pt>
+                <c:pt idx="4">
+                  <c:v>Sem 5</c:v>
+                </c:pt>
+                <c:pt idx="5">
+                  <c:v>Sem 6</c:v>
+                </c:pt>
+                <c:pt idx="6">
+                  <c:v>Sem 7</c:v>
+                </c:pt>
+                <c:pt idx="7">
+                  <c:v>Sem 8</c:v>
+                </c:pt>
+              </c:strCache>
+            </c:strRef>
+          </c:cat>
+          <c:val>
+            <c:numRef>
+              <c:f>Sheet1!$B$2:$B$9</c:f>
+              <c:numCache>
+                <c:formatCode>General</c:formatCode>
+                <c:ptCount val="8"/>
+                <c:pt idx="0">
+                  <c:v>1</c:v>
+                </c:pt>
+                <c:pt idx="1">
+                  <c:v>1</c:v>
+                </c:pt>
+                <c:pt idx="2">
+                  <c:v>1</c:v>
+                </c:pt>
+                <c:pt idx="3">
+                  <c:v>1</c:v>
+                </c:pt>
+                <c:pt idx="4">
+                  <c:v>1</c:v>
+                </c:pt>
+                <c:pt idx="5">
+                  <c:v>1</c:v>
+                </c:pt>
+                <c:pt idx="6">
+                  <c:v>1</c:v>
+                </c:pt>
+                <c:pt idx="7">
+                  <c:v>1</c:v>
+                </c:pt>
+              </c:numCache>
+            </c:numRef>
+          </c:val>
+        </c:ser>
+        <c:gapWidth val="40"/>
+        <c:axId val="-2068027336"/>
+        <c:axId val="-2113994440"/>
+      </c:barChart>
+      <c:catAx>
+        <c:axId val="-2068027336"/>
+        <c:scaling>
+          <c:orientation val="minMax"/>
+        </c:scaling>
+        <c:delete val="0"/>
+        <c:axPos val="b"/>
+        <c:majorTickMark val="out"/>
+        <c:minorTickMark val="none"/>
+        <c:tickLblPos val="nextTo"/>
+        <c:spPr>
+          <a:ln>
+            <a:solidFill>
+              <a:srgbClr val="1A2B4A"/>
+            </a:solidFill>
+          </a:ln>
+        </c:spPr>
+        <c:txPr>
+          <a:bodyPr/>
+          <a:lstStyle/>
+          <a:p>
+            <a:pPr>
+              <a:defRPr sz="1100">
+                <a:solidFill>
+                  <a:srgbClr val="D6D6D6"/>
+                </a:solidFill>
+                <a:latin typeface="Arial"/>
+              </a:defRPr>
+            </a:pPr>
+          </a:p>
+        </c:txPr>
+        <c:crossAx val="-2113994440"/>
+        <c:crosses val="autoZero"/>
+        <c:auto val="1"/>
+        <c:lblAlgn val="ctr"/>
+        <c:lblOffset val="100"/>
+        <c:noMultiLvlLbl val="0"/>
+      </c:catAx>
+      <c:valAx>
+        <c:axId val="-2113994440"/>
+        <c:scaling>
+          <c:max val="1.15"/>
+          <c:min val="0.0"/>
+        </c:scaling>
+        <c:delete/>
+        <c:axPos val="l"/>
+        <c:majorTickMark val="out"/>
+        <c:minorTickMark val="none"/>
+        <c:tickLblPos val="nextTo"/>
+        <c:crossAx val="-2068027336"/>
+        <c:crosses val="autoZero"/>
+      </c:valAx>
+    </c:plotArea>
+    <c:dispBlanksAs val="gap"/>
+  </c:chart>
+  <c:txPr>
+    <a:bodyPr/>
+    <a:lstStyle/>
+    <a:p>
+      <a:pPr>
+        <a:defRPr sz="1800"/>
+      </a:pPr>
+      <a:endParaRPr lang="en-US"/>
+    </a:p>
+  </c:txPr>
+  <c:externalData r:id="rId1">
+    <c:autoUpdate val="0"/>
+  </c:externalData>
+</c:chartSpace>
 </file>
 
 <file path=ppt/notesMasters/notesMaster1.xml><?xml version="1.0" encoding="utf-8"?>
@@ -19502,6 +20100,270 @@
 </p:sld>
 </file>
 
+<file path=ppt/slides/slide25.xml><?xml version="1.0" encoding="utf-8"?>
+<p:sld xmlns:a="http://schemas.openxmlformats.org/drawingml/2006/main" xmlns:r="http://schemas.openxmlformats.org/officeDocument/2006/relationships" xmlns:p="http://schemas.openxmlformats.org/presentationml/2006/main">
+  <p:cSld name="Slide 24">
+    <p:bg>
+      <p:bgPr>
+        <a:solidFill>
+          <a:srgbClr val="070F26"/>
+        </a:solidFill>
+      </p:bgPr>
+    </p:bg>
+    <p:spTree>
+      <p:nvGrpSpPr>
+        <p:cNvPr id="1" name=""/>
+        <p:cNvGrpSpPr/>
+        <p:nvPr/>
+      </p:nvGrpSpPr>
+      <p:grpSpPr>
+        <a:xfrm>
+          <a:off x="0" y="0"/>
+          <a:ext cx="0" cy="0"/>
+          <a:chOff x="0" y="0"/>
+          <a:chExt cx="0" cy="0"/>
+        </a:xfrm>
+      </p:grpSpPr>
+      <p:pic>
+        <p:nvPicPr>
+          <p:cNvPr id="2" name="Image 0" descr="preencoded.png">    </p:cNvPr>
+          <p:cNvPicPr>
+            <a:picLocks noChangeAspect="1"/>
+          </p:cNvPicPr>
+          <p:nvPr/>
+        </p:nvPicPr>
+        <p:blipFill>
+          <a:blip r:embed="rId1"/>
+          <a:stretch>
+            <a:fillRect/>
+          </a:stretch>
+        </p:blipFill>
+        <p:spPr>
+          <a:xfrm>
+            <a:off x="8092440" y="320040"/>
+            <a:ext cx="822960" cy="164592"/>
+          </a:xfrm>
+          <a:prstGeom prst="rect">
+            <a:avLst/>
+          </a:prstGeom>
+        </p:spPr>
+      </p:pic>
+      <p:pic>
+        <p:nvPicPr>
+          <p:cNvPr id="6" name="Image 1" descr="preencoded.png">    </p:cNvPr>
+          <p:cNvPicPr>
+            <a:picLocks noChangeAspect="1"/>
+          </p:cNvPicPr>
+          <p:nvPr/>
+        </p:nvPicPr>
+        <p:blipFill>
+          <a:blip r:embed="rId2"/>
+          <a:stretch>
+            <a:fillRect/>
+          </a:stretch>
+        </p:blipFill>
+        <p:spPr>
+          <a:xfrm>
+            <a:off x="8092440" y="4892040"/>
+            <a:ext cx="822960" cy="164592"/>
+          </a:xfrm>
+          <a:prstGeom prst="rect">
+            <a:avLst/>
+          </a:prstGeom>
+        </p:spPr>
+      </p:pic>
+      <p:sp>
+        <p:nvSpPr>
+          <p:cNvPr id="7" name="Text 2"/>
+          <p:cNvSpPr/>
+          <p:nvPr/>
+        </p:nvSpPr>
+        <p:spPr>
+          <a:xfrm>
+            <a:off x="365760" y="4892040"/>
+            <a:ext cx="2743200" cy="182880"/>
+          </a:xfrm>
+          <a:prstGeom prst="rect">
+            <a:avLst/>
+          </a:prstGeom>
+          <a:noFill/>
+          <a:ln/>
+        </p:spPr>
+        <p:txBody>
+          <a:bodyPr wrap="square" lIns="0" tIns="0" rIns="0" bIns="0" rtlCol="0" anchor="ctr"/>
+          <a:lstStyle/>
+          <a:p>
+            <a:pPr indent="0" marL="0">
+              <a:buNone/>
+            </a:pPr>
+            <a:r>
+              <a:rPr lang="en-US" sz="900" dirty="0">
+                <a:solidFill>
+                  <a:srgbClr val="D6D6D6"/>
+                </a:solidFill>
+                <a:latin typeface="Arial" pitchFamily="34" charset="0"/>
+                <a:ea typeface="Arial" pitchFamily="34" charset="-122"/>
+                <a:cs typeface="Arial" pitchFamily="34" charset="-120"/>
+              </a:rPr>
+              <a:t>© 2026 NTT DATA, Inc.</a:t>
+            </a:r>
+            <a:endParaRPr lang="en-US" sz="900" dirty="0"/>
+          </a:p>
+        </p:txBody>
+      </p:sp>
+      <p:sp>
+        <p:nvSpPr>
+          <p:cNvPr id="8" name="Text 3"/>
+          <p:cNvSpPr/>
+          <p:nvPr/>
+        </p:nvSpPr>
+        <p:spPr>
+          <a:xfrm>
+            <a:off x="8595360" y="4892040"/>
+            <a:ext cx="274320" cy="182880"/>
+          </a:xfrm>
+          <a:prstGeom prst="rect">
+            <a:avLst/>
+          </a:prstGeom>
+          <a:noFill/>
+          <a:ln/>
+        </p:spPr>
+        <p:txBody>
+          <a:bodyPr wrap="square" lIns="0" tIns="0" rIns="0" bIns="0" rtlCol="0" anchor="ctr"/>
+          <a:lstStyle/>
+          <a:p>
+            <a:pPr algn="r" indent="0" marL="0">
+              <a:buNone/>
+            </a:pPr>
+            <a:r>
+              <a:rPr lang="en-US" sz="900" dirty="0">
+                <a:solidFill>
+                  <a:srgbClr val="D6D6D6"/>
+                </a:solidFill>
+                <a:latin typeface="Arial" pitchFamily="34" charset="0"/>
+                <a:ea typeface="Arial" pitchFamily="34" charset="-122"/>
+                <a:cs typeface="Arial" pitchFamily="34" charset="-120"/>
+              </a:rPr>
+              <a:t>25</a:t>
+            </a:r>
+            <a:endParaRPr lang="en-US" sz="900" dirty="0"/>
+          </a:p>
+        </p:txBody>
+      </p:sp>
+      <p:sp>
+        <p:nvSpPr>
+          <p:cNvPr id="9" name="TextBox 8"/>
+          <p:cNvSpPr txBox="1"/>
+          <p:nvPr/>
+        </p:nvSpPr>
+        <p:spPr>
+          <a:xfrm>
+            <a:off x="365760" y="274320"/>
+            <a:ext cx="7772400" cy="457200"/>
+          </a:xfrm>
+          <a:prstGeom prst="rect">
+            <a:avLst/>
+          </a:prstGeom>
+          <a:noFill/>
+        </p:spPr>
+        <p:txBody>
+          <a:bodyPr wrap="square" lIns="25400" rIns="25400" tIns="12700" bIns="12700" anchor="t">
+            <a:spAutoFit/>
+          </a:bodyPr>
+          <a:lstStyle/>
+          <a:p>
+            <a:pPr algn="l"/>
+            <a:r>
+              <a:rPr sz="2800" b="1">
+                <a:solidFill>
+                  <a:srgbClr val="FFFFFF"/>
+                </a:solidFill>
+                <a:latin typeface="Noto Sans"/>
+              </a:rPr>
+              <a:t>Avance del Roadmap</a:t>
+            </a:r>
+          </a:p>
+        </p:txBody>
+      </p:sp>
+      <p:sp>
+        <p:nvSpPr>
+          <p:cNvPr id="10" name="TextBox 9"/>
+          <p:cNvSpPr txBox="1"/>
+          <p:nvPr/>
+        </p:nvSpPr>
+        <p:spPr>
+          <a:xfrm>
+            <a:off x="365760" y="749808"/>
+            <a:ext cx="8138160" cy="274320"/>
+          </a:xfrm>
+          <a:prstGeom prst="rect">
+            <a:avLst/>
+          </a:prstGeom>
+          <a:noFill/>
+        </p:spPr>
+        <p:txBody>
+          <a:bodyPr wrap="square" lIns="25400" rIns="25400" tIns="12700" bIns="12700" anchor="t">
+            <a:spAutoFit/>
+          </a:bodyPr>
+          <a:lstStyle/>
+          <a:p>
+            <a:pPr algn="l"/>
+            <a:r>
+              <a:rPr sz="1200" b="0">
+                <a:solidFill>
+                  <a:srgbClr val="00DFED"/>
+                </a:solidFill>
+                <a:latin typeface="Noto Sans"/>
+              </a:rPr>
+              <a:t>Semanas numeradas (1–8) del plan de adopción · Actualizado al 07 sep 2026 (Semana 4 en curso)</a:t>
+            </a:r>
+          </a:p>
+        </p:txBody>
+      </p:sp>
+      <p:graphicFrame>
+        <p:nvGraphicFramePr>
+          <p:cNvPr id="11" name="Chart 10"/>
+          <p:cNvGraphicFramePr>
+            <a:graphicFrameLocks noGrp="1"/>
+          </p:cNvGraphicFramePr>
+          <p:nvPr/>
+        </p:nvGraphicFramePr>
+        <p:xfrm>
+          <a:off x="365760" y="1170432"/>
+          <a:ext cx="8503920" cy="1234440"/>
+        </p:xfrm>
+        <a:graphic>
+          <a:graphicData uri="http://schemas.openxmlformats.org/drawingml/2006/chart">
+            <c:chart xmlns:c="http://schemas.openxmlformats.org/drawingml/2006/chart" r:id="rId4"/>
+          </a:graphicData>
+        </a:graphic>
+      </p:graphicFrame>
+      <p:graphicFrame>
+        <p:nvGraphicFramePr>
+          <p:cNvPr id="12" name="Chart 11"/>
+          <p:cNvGraphicFramePr>
+            <a:graphicFrameLocks noGrp="1"/>
+          </p:cNvGraphicFramePr>
+          <p:nvPr/>
+        </p:nvGraphicFramePr>
+        <p:xfrm>
+          <a:off x="365760" y="2697480"/>
+          <a:ext cx="8503920" cy="1965960"/>
+        </p:xfrm>
+        <a:graphic>
+          <a:graphicData uri="http://schemas.openxmlformats.org/drawingml/2006/chart">
+            <c:chart xmlns:c="http://schemas.openxmlformats.org/drawingml/2006/chart" r:id="rId5"/>
+          </a:graphicData>
+        </a:graphic>
+      </p:graphicFrame>
+    </p:spTree>
+  </p:cSld>
+  <p:clrMapOvr>
+    <a:masterClrMapping/>
+  </p:clrMapOvr>
+</p:sld>
+</file>
+
 <file path=ppt/slides/slide26.xml><?xml version="1.0" encoding="utf-8"?>
 <p:sld xmlns:a="http://schemas.openxmlformats.org/drawingml/2006/main" xmlns:r="http://schemas.openxmlformats.org/officeDocument/2006/relationships" xmlns:p="http://schemas.openxmlformats.org/presentationml/2006/main">
   <p:cSld name="Slide 26">
@@ -21185,7 +22047,7 @@
                 <a:ea typeface="Arial" pitchFamily="34" charset="-122"/>
                 <a:cs typeface="Arial" pitchFamily="34" charset="-120"/>
               </a:rPr>
-              <a:t>25</a:t>
+              <a:t>26</a:t>
             </a:r>
             <a:endParaRPr lang="en-US" sz="900" dirty="0"/>
           </a:p>
@@ -23085,7 +23947,7 @@
                 <a:ea typeface="Arial" pitchFamily="34" charset="-122"/>
                 <a:cs typeface="Arial" pitchFamily="34" charset="-120"/>
               </a:rPr>
-              <a:t>26</a:t>
+              <a:t>27</a:t>
             </a:r>
             <a:endParaRPr lang="en-US" sz="900" dirty="0"/>
           </a:p>
@@ -24576,7 +25438,7 @@
                 <a:ea typeface="Arial" pitchFamily="34" charset="-122"/>
                 <a:cs typeface="Arial" pitchFamily="34" charset="-120"/>
               </a:rPr>
-              <a:t>27</a:t>
+              <a:t>28</a:t>
             </a:r>
             <a:endParaRPr lang="en-US" sz="900" dirty="0"/>
           </a:p>
@@ -25586,7 +26448,7 @@
                 <a:ea typeface="Arial" pitchFamily="34" charset="-122"/>
                 <a:cs typeface="Arial" pitchFamily="34" charset="-120"/>
               </a:rPr>
-              <a:t>28</a:t>
+              <a:t>29</a:t>
             </a:r>
             <a:endParaRPr lang="en-US" sz="900" dirty="0"/>
           </a:p>
@@ -26578,7 +27440,7 @@
                 <a:ea typeface="Arial" pitchFamily="34" charset="-122"/>
                 <a:cs typeface="Arial" pitchFamily="34" charset="-120"/>
               </a:rPr>
-              <a:t>29</a:t>
+              <a:t>30</a:t>
             </a:r>
             <a:endParaRPr lang="en-US" sz="900" dirty="0"/>
           </a:p>
@@ -27798,7 +28660,7 @@
                 <a:ea typeface="Arial" pitchFamily="34" charset="-122"/>
                 <a:cs typeface="Arial" pitchFamily="34" charset="-120"/>
               </a:rPr>
-              <a:t>30</a:t>
+              <a:t>31</a:t>
             </a:r>
             <a:endParaRPr lang="en-US" sz="900" dirty="0"/>
           </a:p>
@@ -28916,7 +29778,7 @@
                 <a:ea typeface="Arial" pitchFamily="34" charset="-122"/>
                 <a:cs typeface="Arial" pitchFamily="34" charset="-120"/>
               </a:rPr>
-              <a:t>31</a:t>
+              <a:t>32</a:t>
             </a:r>
             <a:endParaRPr lang="en-US" sz="900" dirty="0"/>
           </a:p>
@@ -29272,7 +30134,7 @@
                 <a:ea typeface="Arial" pitchFamily="34" charset="-122"/>
                 <a:cs typeface="Arial" pitchFamily="34" charset="-120"/>
               </a:rPr>
-              <a:t>32</a:t>
+              <a:t>33</a:t>
             </a:r>
             <a:endParaRPr lang="en-US" sz="900" dirty="0"/>
           </a:p>

</xml_diff>